<commit_message>
Visual enhancements to the deck
</commit_message>
<xml_diff>
--- a/templates/standard_proposal_template_v1.pptx
+++ b/templates/standard_proposal_template_v1.pptx
@@ -4,7 +4,7 @@
   <p:sldMasterIdLst>
     <p:sldMasterId id="2147483648" r:id="rId1"/>
   </p:sldMasterIdLst>
-  <p:sldSz cx="9144000" cy="6858000" type="screen4x3"/>
+  <p:sldSz cx="9144000" cy="5143500" type="screen4x3"/>
   <p:notesSz cx="6858000" cy="9144000"/>
   <p:defaultTextStyle>
     <a:defPPr>
@@ -1957,71 +1957,6 @@
           <a:chExt cx="0" cy="0"/>
         </a:xfrm>
       </p:grpSpPr>
-      <p:sp>
-        <p:nvSpPr>
-          <p:cNvPr id="2" name="Date Placeholder 1"/>
-          <p:cNvSpPr>
-            <a:spLocks noGrp="1"/>
-          </p:cNvSpPr>
-          <p:nvPr>
-            <p:ph type="dt" sz="half" idx="10"/>
-          </p:nvPr>
-        </p:nvSpPr>
-        <p:spPr/>
-        <p:txBody>
-          <a:bodyPr/>
-          <a:lstStyle/>
-          <a:p>
-            <a:fld id="{5BCAD085-E8A6-8845-BD4E-CB4CCA059FC4}" type="datetimeFigureOut">
-              <a:rPr lang="en-US" smtClean="0"/>
-              <a:t>1/27/13</a:t>
-            </a:fld>
-            <a:endParaRPr lang="en-US"/>
-          </a:p>
-        </p:txBody>
-      </p:sp>
-      <p:sp>
-        <p:nvSpPr>
-          <p:cNvPr id="3" name="Footer Placeholder 2"/>
-          <p:cNvSpPr>
-            <a:spLocks noGrp="1"/>
-          </p:cNvSpPr>
-          <p:nvPr>
-            <p:ph type="ftr" sz="quarter" idx="11"/>
-          </p:nvPr>
-        </p:nvSpPr>
-        <p:spPr/>
-        <p:txBody>
-          <a:bodyPr/>
-          <a:lstStyle/>
-          <a:p>
-            <a:endParaRPr lang="en-US"/>
-          </a:p>
-        </p:txBody>
-      </p:sp>
-      <p:sp>
-        <p:nvSpPr>
-          <p:cNvPr id="4" name="Slide Number Placeholder 3"/>
-          <p:cNvSpPr>
-            <a:spLocks noGrp="1"/>
-          </p:cNvSpPr>
-          <p:nvPr>
-            <p:ph type="sldNum" sz="quarter" idx="12"/>
-          </p:nvPr>
-        </p:nvSpPr>
-        <p:spPr/>
-        <p:txBody>
-          <a:bodyPr/>
-          <a:lstStyle/>
-          <a:p>
-            <a:fld id="{C1FF6DA9-008F-8B48-92A6-B652298478BF}" type="slidenum">
-              <a:rPr lang="en-US" smtClean="0"/>
-              <a:t>‹#›</a:t>
-            </a:fld>
-            <a:endParaRPr lang="en-US"/>
-          </a:p>
-        </p:txBody>
-      </p:sp>
     </p:spTree>
     <p:extLst>
       <p:ext uri="{BB962C8B-B14F-4D97-AF65-F5344CB8AC3E}">
@@ -3080,40 +3015,40 @@
   <a:themeElements>
     <a:clrScheme name="Office">
       <a:dk1>
-        <a:sysClr val="windowText" lastClr="000000"/>
+        <a:srgbClr val="1E2761"/>
       </a:dk1>
       <a:lt1>
-        <a:sysClr val="window" lastClr="FFFFFF"/>
+        <a:srgbClr val="FFFFFF"/>
       </a:lt1>
       <a:dk2>
-        <a:srgbClr val="1F497D"/>
+        <a:srgbClr val="1E2761"/>
       </a:dk2>
       <a:lt2>
-        <a:srgbClr val="EEECE1"/>
+        <a:srgbClr val="CADCFC"/>
       </a:lt2>
       <a:accent1>
-        <a:srgbClr val="4F81BD"/>
+        <a:srgbClr val="4FC3F7"/>
       </a:accent1>
       <a:accent2>
-        <a:srgbClr val="C0504D"/>
+        <a:srgbClr val="27AE60"/>
       </a:accent2>
       <a:accent3>
-        <a:srgbClr val="9BBB59"/>
+        <a:srgbClr val="1E2761"/>
       </a:accent3>
       <a:accent4>
-        <a:srgbClr val="8064A2"/>
+        <a:srgbClr val="CADCFC"/>
       </a:accent4>
       <a:accent5>
-        <a:srgbClr val="4BACC6"/>
+        <a:srgbClr val="8A93A8"/>
       </a:accent5>
       <a:accent6>
-        <a:srgbClr val="F79646"/>
+        <a:srgbClr val="DCE6F2"/>
       </a:accent6>
       <a:hlink>
-        <a:srgbClr val="0000FF"/>
+        <a:srgbClr val="4FC3F7"/>
       </a:hlink>
       <a:folHlink>
-        <a:srgbClr val="800080"/>
+        <a:srgbClr val="CADCFC"/>
       </a:folHlink>
     </a:clrScheme>
     <a:fontScheme name="Office">

</xml_diff>